<commit_message>
Complete coursework bibliography and fill assignment details
</commit_message>
<xml_diff>
--- a/docs/defense/catalog_defense.pptx
+++ b/docs/defense/catalog_defense.pptx
@@ -509,7 +509,7 @@
           <a:lstStyle/>
           <a:p>
             <a:r>
-              <a:t>Представиться, назвать тему и цель. Личные реквизиты заполнить перед защитой. Это действующее локальное приложение, а не внедрённая промышленная система.</a:t>
+              <a:t>Представиться, назвать тему и цель. Автор: Чемоданов Никита Сергеевич, группа ИПо-41. Это действующее локальное приложение, а не внедрённая промышленная система.</a:t>
             </a:r>
           </a:p>
         </p:txBody>
@@ -4275,8 +4275,8 @@
         </p:nvSpPr>
         <p:spPr>
           <a:xfrm>
-            <a:off x="777240" y="4572000"/>
-            <a:ext cx="9966960" cy="822960"/>
+            <a:off x="777240" y="4434840"/>
+            <a:ext cx="10607040" cy="1600200"/>
           </a:xfrm>
           <a:prstGeom prst="rect">
             <a:avLst/>
@@ -4293,7 +4293,7 @@
               <a:spcAft>
                 <a:spcPts val="1200"/>
               </a:spcAft>
-              <a:defRPr sz="1900" b="0">
+              <a:defRPr sz="1700" b="0">
                 <a:solidFill>
                   <a:srgbClr val="64748B"/>
                 </a:solidFill>
@@ -4301,15 +4301,15 @@
               </a:defRPr>
             </a:pPr>
             <a:r>
-              <a:t>[ФИО] · [Группа]</a:t>
-            </a:r>
-          </a:p>
-          <a:p>
-            <a:pPr>
-              <a:spcAft>
-                <a:spcPts val="1200"/>
-              </a:spcAft>
-              <a:defRPr sz="1900" b="0">
+              <a:t>Чемоданов Никита Сергеевич · ИПо-41</a:t>
+            </a:r>
+          </a:p>
+          <a:p>
+            <a:pPr>
+              <a:spcAft>
+                <a:spcPts val="1200"/>
+              </a:spcAft>
+              <a:defRPr sz="1700" b="0">
                 <a:solidFill>
                   <a:srgbClr val="64748B"/>
                 </a:solidFill>
@@ -4317,7 +4317,23 @@
               </a:defRPr>
             </a:pPr>
             <a:r>
-              <a:t>[Дисциплина] · Руководитель: [ФИО]</a:t>
+              <a:t>Разработка программных модулей</a:t>
+            </a:r>
+          </a:p>
+          <a:p>
+            <a:pPr>
+              <a:spcAft>
+                <a:spcPts val="1200"/>
+              </a:spcAft>
+              <a:defRPr sz="1700" b="0">
+                <a:solidFill>
+                  <a:srgbClr val="64748B"/>
+                </a:solidFill>
+                <a:latin typeface="Arial"/>
+              </a:defRPr>
+            </a:pPr>
+            <a:r>
+              <a:t>Руководитель: Колпащиков Кирилл Александрович · Киров, 2026</a:t>
             </a:r>
           </a:p>
         </p:txBody>

</xml_diff>

<commit_message>
Expand coursework to 32 main pages and remove interface icons
</commit_message>
<xml_diff>
--- a/docs/defense/catalog_defense.pptx
+++ b/docs/defense/catalog_defense.pptx
@@ -509,7 +509,7 @@
           <a:lstStyle/>
           <a:p>
             <a:r>
-              <a:t>Представиться, назвать тему и цель. Автор: Чемоданов Никита Сергеевич, группа ИПо-41. Это действующее локальное приложение, а не внедрённая промышленная система.</a:t>
+              <a:t>Представиться, назвать тему и цель. Автор: Чемоданов Никита Сергеевич, группа ИПо-41. Приложение запускается локально и хранит каталог в SQLite.</a:t>
             </a:r>
           </a:p>
         </p:txBody>
@@ -789,7 +789,7 @@
           <a:lstStyle/>
           <a:p>
             <a:r>
-              <a:t>Показать реальный список. Фильтры применяются вместе, сохраняются в URL и ссылках страниц. Подчеркнуть, что интерфейс использует локальные стили и основные формы работают без JavaScript.</a:t>
+              <a:t>Показать реальный список. Фильтры применяются вместе, сохраняются в URL и ссылках страниц. Показать форму; стили загружаются локально, основные операции доступны без JavaScript.</a:t>
             </a:r>
           </a:p>
         </p:txBody>
@@ -859,7 +859,7 @@
           <a:lstStyle/>
           <a:p>
             <a:r>
-              <a:t>1200 товаров в 12 категориях. Цены и остатки условные. Загрузчик сохраняет backup, пропускает существующие артикулы, добавляет недостающее одной транзакцией. Повторный запуск не возвращает изменённую цену к исходной.</a:t>
+              <a:t>1200 товаров в 12 категориях. Цены и остатки заданы для демонстрации. Загрузчик сохраняет backup, пропускает существующие артикулы, добавляет недостающее одной транзакцией. Повторный запуск не возвращает изменённую цену к исходной.</a:t>
             </a:r>
           </a:p>
         </p:txBody>
@@ -999,7 +999,7 @@
           <a:lstStyle/>
           <a:p>
             <a:r>
-              <a:t>Завершить перечислением результата. Обозначить отсутствие авторизации, миграций и журнала остатков. Дальнейшее развитие — роли пользователей, история операций и проверка одновременной работы. Приступить к короткой живой демонстрации.</a:t>
+              <a:t>Назвать реализованные операции. Пояснить, что авторизация, миграции и журнал остатков пока отсутствуют. Для работы нескольких менеджеров потребуется проверка одновременной записи. Затем показать приложение.</a:t>
             </a:r>
           </a:p>
         </p:txBody>
@@ -4301,7 +4301,7 @@
               </a:defRPr>
             </a:pPr>
             <a:r>
-              <a:t>Чемоданов Никита Сергеевич · ИПо-41</a:t>
+              <a:t>Чемоданов Никита Сергеевич</a:t>
             </a:r>
           </a:p>
           <a:p>
@@ -4317,7 +4317,7 @@
               </a:defRPr>
             </a:pPr>
             <a:r>
-              <a:t>Разработка программных модулей</a:t>
+              <a:t>23ИПо8381 (ИПо-41) · 4-й курс · Разработка программных модулей</a:t>
             </a:r>
           </a:p>
           <a:p>
@@ -5413,7 +5413,7 @@
               </a:defRPr>
             </a:pPr>
             <a:r>
-              <a:t>Название — уникальное</a:t>
+              <a:t>Название — уникальное без учёта регистра</a:t>
             </a:r>
           </a:p>
           <a:p>
@@ -8571,7 +8571,7 @@
               </a:defRPr>
             </a:pPr>
             <a:r>
-              <a:t>Результат и развитие</a:t>
+              <a:t>Результат и ограничения</a:t>
             </a:r>
           </a:p>
         </p:txBody>
@@ -8610,7 +8610,7 @@
               </a:defRPr>
             </a:pPr>
             <a:r>
-              <a:t>Согласованные функции каталога реализованы</a:t>
+              <a:t>Локальный каталог с веб-формами и JSON API</a:t>
             </a:r>
           </a:p>
         </p:txBody>
@@ -8939,7 +8939,7 @@
               </a:defRPr>
             </a:pPr>
             <a:r>
-              <a:t>НАПРАВЛЕНИЯ РАЗВИТИЯ</a:t>
+              <a:t>ДЛЯ НЕСКОЛЬКИХ МЕНЕДЖЕРОВ</a:t>
             </a:r>
           </a:p>
         </p:txBody>

</xml_diff>